<commit_message>
Add Python optimisation model and analysed results
</commit_message>
<xml_diff>
--- a/docs/2025_Microgrid_Project.pptx
+++ b/docs/2025_Microgrid_Project.pptx
@@ -207,7 +207,7 @@
           <a:p>
             <a:fld id="{51E4A241-7145-419B-8319-709E20F6D895}" type="datetimeFigureOut">
               <a:rPr lang="it-IT" smtClean="0"/>
-              <a:t>24/11/2025</a:t>
+              <a:t>04/08/2026</a:t>
             </a:fld>
             <a:endParaRPr lang="it-IT"/>
           </a:p>
@@ -273,7 +273,7 @@
           <a:p>
             <a:fld id="{A3456A78-4253-44C9-BC09-7035D4952A12}" type="slidenum">
               <a:rPr lang="it-IT" smtClean="0"/>
-              <a:t>‹N›</a:t>
+              <a:t>‹#›</a:t>
             </a:fld>
             <a:endParaRPr lang="it-IT"/>
           </a:p>
@@ -1091,7 +1091,7 @@
           <a:p>
             <a:fld id="{643C5E4E-1A97-47B6-95B8-E397CC0DA4DF}" type="datetimeFigureOut">
               <a:rPr lang="it-IT" smtClean="0"/>
-              <a:t>24/11/2025</a:t>
+              <a:t>04/08/2026</a:t>
             </a:fld>
             <a:endParaRPr lang="it-IT"/>
           </a:p>
@@ -1133,7 +1133,7 @@
           <a:p>
             <a:fld id="{AEDE0572-A9A8-4C66-BEDA-92FFA5622382}" type="slidenum">
               <a:rPr lang="it-IT" smtClean="0"/>
-              <a:t>‹N›</a:t>
+              <a:t>‹#›</a:t>
             </a:fld>
             <a:endParaRPr lang="it-IT"/>
           </a:p>
@@ -1342,7 +1342,7 @@
           <a:p>
             <a:fld id="{643C5E4E-1A97-47B6-95B8-E397CC0DA4DF}" type="datetimeFigureOut">
               <a:rPr lang="it-IT" smtClean="0"/>
-              <a:t>24/11/2025</a:t>
+              <a:t>04/08/2026</a:t>
             </a:fld>
             <a:endParaRPr lang="it-IT"/>
           </a:p>
@@ -1384,7 +1384,7 @@
           <a:p>
             <a:fld id="{AEDE0572-A9A8-4C66-BEDA-92FFA5622382}" type="slidenum">
               <a:rPr lang="it-IT" smtClean="0"/>
-              <a:t>‹N›</a:t>
+              <a:t>‹#›</a:t>
             </a:fld>
             <a:endParaRPr lang="it-IT"/>
           </a:p>
@@ -1656,7 +1656,7 @@
           <a:p>
             <a:fld id="{643C5E4E-1A97-47B6-95B8-E397CC0DA4DF}" type="datetimeFigureOut">
               <a:rPr lang="it-IT" smtClean="0"/>
-              <a:t>24/11/2025</a:t>
+              <a:t>04/08/2026</a:t>
             </a:fld>
             <a:endParaRPr lang="it-IT"/>
           </a:p>
@@ -1698,7 +1698,7 @@
           <a:p>
             <a:fld id="{AEDE0572-A9A8-4C66-BEDA-92FFA5622382}" type="slidenum">
               <a:rPr lang="it-IT" smtClean="0"/>
-              <a:t>‹N›</a:t>
+              <a:t>‹#›</a:t>
             </a:fld>
             <a:endParaRPr lang="it-IT"/>
           </a:p>
@@ -1989,7 +1989,7 @@
           <a:p>
             <a:fld id="{643C5E4E-1A97-47B6-95B8-E397CC0DA4DF}" type="datetimeFigureOut">
               <a:rPr lang="it-IT" smtClean="0"/>
-              <a:t>24/11/2025</a:t>
+              <a:t>04/08/2026</a:t>
             </a:fld>
             <a:endParaRPr lang="it-IT"/>
           </a:p>
@@ -2031,7 +2031,7 @@
           <a:p>
             <a:fld id="{AEDE0572-A9A8-4C66-BEDA-92FFA5622382}" type="slidenum">
               <a:rPr lang="it-IT" smtClean="0"/>
-              <a:t>‹N›</a:t>
+              <a:t>‹#›</a:t>
             </a:fld>
             <a:endParaRPr lang="it-IT"/>
           </a:p>
@@ -2303,7 +2303,7 @@
           <a:p>
             <a:fld id="{643C5E4E-1A97-47B6-95B8-E397CC0DA4DF}" type="datetimeFigureOut">
               <a:rPr lang="it-IT" smtClean="0"/>
-              <a:t>24/11/2025</a:t>
+              <a:t>04/08/2026</a:t>
             </a:fld>
             <a:endParaRPr lang="it-IT"/>
           </a:p>
@@ -2345,7 +2345,7 @@
           <a:p>
             <a:fld id="{AEDE0572-A9A8-4C66-BEDA-92FFA5622382}" type="slidenum">
               <a:rPr lang="it-IT" smtClean="0"/>
-              <a:t>‹N›</a:t>
+              <a:t>‹#›</a:t>
             </a:fld>
             <a:endParaRPr lang="it-IT"/>
           </a:p>
@@ -2696,7 +2696,7 @@
           <a:p>
             <a:fld id="{643C5E4E-1A97-47B6-95B8-E397CC0DA4DF}" type="datetimeFigureOut">
               <a:rPr lang="it-IT" smtClean="0"/>
-              <a:t>24/11/2025</a:t>
+              <a:t>04/08/2026</a:t>
             </a:fld>
             <a:endParaRPr lang="it-IT"/>
           </a:p>
@@ -2738,7 +2738,7 @@
           <a:p>
             <a:fld id="{AEDE0572-A9A8-4C66-BEDA-92FFA5622382}" type="slidenum">
               <a:rPr lang="it-IT" smtClean="0"/>
-              <a:t>‹N›</a:t>
+              <a:t>‹#›</a:t>
             </a:fld>
             <a:endParaRPr lang="it-IT"/>
           </a:p>
@@ -2866,7 +2866,7 @@
           <a:p>
             <a:fld id="{643C5E4E-1A97-47B6-95B8-E397CC0DA4DF}" type="datetimeFigureOut">
               <a:rPr lang="it-IT" smtClean="0"/>
-              <a:t>24/11/2025</a:t>
+              <a:t>04/08/2026</a:t>
             </a:fld>
             <a:endParaRPr lang="it-IT"/>
           </a:p>
@@ -2908,7 +2908,7 @@
           <a:p>
             <a:fld id="{AEDE0572-A9A8-4C66-BEDA-92FFA5622382}" type="slidenum">
               <a:rPr lang="it-IT" smtClean="0"/>
-              <a:t>‹N›</a:t>
+              <a:t>‹#›</a:t>
             </a:fld>
             <a:endParaRPr lang="it-IT"/>
           </a:p>
@@ -3046,7 +3046,7 @@
           <a:p>
             <a:fld id="{643C5E4E-1A97-47B6-95B8-E397CC0DA4DF}" type="datetimeFigureOut">
               <a:rPr lang="it-IT" smtClean="0"/>
-              <a:t>24/11/2025</a:t>
+              <a:t>04/08/2026</a:t>
             </a:fld>
             <a:endParaRPr lang="it-IT"/>
           </a:p>
@@ -3088,7 +3088,7 @@
           <a:p>
             <a:fld id="{AEDE0572-A9A8-4C66-BEDA-92FFA5622382}" type="slidenum">
               <a:rPr lang="it-IT" smtClean="0"/>
-              <a:t>‹N›</a:t>
+              <a:t>‹#›</a:t>
             </a:fld>
             <a:endParaRPr lang="it-IT"/>
           </a:p>
@@ -3216,7 +3216,7 @@
           <a:p>
             <a:fld id="{643C5E4E-1A97-47B6-95B8-E397CC0DA4DF}" type="datetimeFigureOut">
               <a:rPr lang="it-IT" smtClean="0"/>
-              <a:t>24/11/2025</a:t>
+              <a:t>04/08/2026</a:t>
             </a:fld>
             <a:endParaRPr lang="it-IT"/>
           </a:p>
@@ -3258,7 +3258,7 @@
           <a:p>
             <a:fld id="{AEDE0572-A9A8-4C66-BEDA-92FFA5622382}" type="slidenum">
               <a:rPr lang="it-IT" smtClean="0"/>
-              <a:t>‹N›</a:t>
+              <a:t>‹#›</a:t>
             </a:fld>
             <a:endParaRPr lang="it-IT"/>
           </a:p>
@@ -3463,7 +3463,7 @@
           <a:p>
             <a:fld id="{643C5E4E-1A97-47B6-95B8-E397CC0DA4DF}" type="datetimeFigureOut">
               <a:rPr lang="it-IT" smtClean="0"/>
-              <a:t>24/11/2025</a:t>
+              <a:t>04/08/2026</a:t>
             </a:fld>
             <a:endParaRPr lang="it-IT"/>
           </a:p>
@@ -3505,7 +3505,7 @@
           <a:p>
             <a:fld id="{AEDE0572-A9A8-4C66-BEDA-92FFA5622382}" type="slidenum">
               <a:rPr lang="it-IT" smtClean="0"/>
-              <a:t>‹N›</a:t>
+              <a:t>‹#›</a:t>
             </a:fld>
             <a:endParaRPr lang="it-IT"/>
           </a:p>
@@ -3695,7 +3695,7 @@
           <a:p>
             <a:fld id="{643C5E4E-1A97-47B6-95B8-E397CC0DA4DF}" type="datetimeFigureOut">
               <a:rPr lang="it-IT" smtClean="0"/>
-              <a:t>24/11/2025</a:t>
+              <a:t>04/08/2026</a:t>
             </a:fld>
             <a:endParaRPr lang="it-IT"/>
           </a:p>
@@ -3737,7 +3737,7 @@
           <a:p>
             <a:fld id="{AEDE0572-A9A8-4C66-BEDA-92FFA5622382}" type="slidenum">
               <a:rPr lang="it-IT" smtClean="0"/>
-              <a:t>‹N›</a:t>
+              <a:t>‹#›</a:t>
             </a:fld>
             <a:endParaRPr lang="it-IT"/>
           </a:p>
@@ -4069,7 +4069,7 @@
           <a:p>
             <a:fld id="{643C5E4E-1A97-47B6-95B8-E397CC0DA4DF}" type="datetimeFigureOut">
               <a:rPr lang="it-IT" smtClean="0"/>
-              <a:t>24/11/2025</a:t>
+              <a:t>04/08/2026</a:t>
             </a:fld>
             <a:endParaRPr lang="it-IT"/>
           </a:p>
@@ -4111,7 +4111,7 @@
           <a:p>
             <a:fld id="{AEDE0572-A9A8-4C66-BEDA-92FFA5622382}" type="slidenum">
               <a:rPr lang="it-IT" smtClean="0"/>
-              <a:t>‹N›</a:t>
+              <a:t>‹#›</a:t>
             </a:fld>
             <a:endParaRPr lang="it-IT"/>
           </a:p>
@@ -4192,7 +4192,7 @@
           <a:p>
             <a:fld id="{643C5E4E-1A97-47B6-95B8-E397CC0DA4DF}" type="datetimeFigureOut">
               <a:rPr lang="it-IT" smtClean="0"/>
-              <a:t>24/11/2025</a:t>
+              <a:t>04/08/2026</a:t>
             </a:fld>
             <a:endParaRPr lang="it-IT"/>
           </a:p>
@@ -4234,7 +4234,7 @@
           <a:p>
             <a:fld id="{AEDE0572-A9A8-4C66-BEDA-92FFA5622382}" type="slidenum">
               <a:rPr lang="it-IT" smtClean="0"/>
-              <a:t>‹N›</a:t>
+              <a:t>‹#›</a:t>
             </a:fld>
             <a:endParaRPr lang="it-IT"/>
           </a:p>
@@ -4287,7 +4287,7 @@
           <a:p>
             <a:fld id="{643C5E4E-1A97-47B6-95B8-E397CC0DA4DF}" type="datetimeFigureOut">
               <a:rPr lang="it-IT" smtClean="0"/>
-              <a:t>24/11/2025</a:t>
+              <a:t>04/08/2026</a:t>
             </a:fld>
             <a:endParaRPr lang="it-IT"/>
           </a:p>
@@ -4329,7 +4329,7 @@
           <a:p>
             <a:fld id="{AEDE0572-A9A8-4C66-BEDA-92FFA5622382}" type="slidenum">
               <a:rPr lang="it-IT" smtClean="0"/>
-              <a:t>‹N›</a:t>
+              <a:t>‹#›</a:t>
             </a:fld>
             <a:endParaRPr lang="it-IT"/>
           </a:p>
@@ -4542,7 +4542,7 @@
           <a:p>
             <a:fld id="{643C5E4E-1A97-47B6-95B8-E397CC0DA4DF}" type="datetimeFigureOut">
               <a:rPr lang="it-IT" smtClean="0"/>
-              <a:t>24/11/2025</a:t>
+              <a:t>04/08/2026</a:t>
             </a:fld>
             <a:endParaRPr lang="it-IT"/>
           </a:p>
@@ -4584,7 +4584,7 @@
           <a:p>
             <a:fld id="{AEDE0572-A9A8-4C66-BEDA-92FFA5622382}" type="slidenum">
               <a:rPr lang="it-IT" smtClean="0"/>
-              <a:t>‹N›</a:t>
+              <a:t>‹#›</a:t>
             </a:fld>
             <a:endParaRPr lang="it-IT"/>
           </a:p>
@@ -4824,7 +4824,7 @@
           <a:p>
             <a:fld id="{AEDE0572-A9A8-4C66-BEDA-92FFA5622382}" type="slidenum">
               <a:rPr lang="it-IT" smtClean="0"/>
-              <a:t>‹N›</a:t>
+              <a:t>‹#›</a:t>
             </a:fld>
             <a:endParaRPr lang="it-IT"/>
           </a:p>
@@ -4847,7 +4847,7 @@
           <a:p>
             <a:fld id="{643C5E4E-1A97-47B6-95B8-E397CC0DA4DF}" type="datetimeFigureOut">
               <a:rPr lang="it-IT" smtClean="0"/>
-              <a:t>24/11/2025</a:t>
+              <a:t>04/08/2026</a:t>
             </a:fld>
             <a:endParaRPr lang="it-IT"/>
           </a:p>
@@ -5605,7 +5605,7 @@
           <a:p>
             <a:fld id="{643C5E4E-1A97-47B6-95B8-E397CC0DA4DF}" type="datetimeFigureOut">
               <a:rPr lang="it-IT" smtClean="0"/>
-              <a:t>24/11/2025</a:t>
+              <a:t>04/08/2026</a:t>
             </a:fld>
             <a:endParaRPr lang="it-IT"/>
           </a:p>
@@ -5681,7 +5681,7 @@
           <a:p>
             <a:fld id="{AEDE0572-A9A8-4C66-BEDA-92FFA5622382}" type="slidenum">
               <a:rPr lang="it-IT" smtClean="0"/>
-              <a:t>‹N›</a:t>
+              <a:t>‹#›</a:t>
             </a:fld>
             <a:endParaRPr lang="it-IT"/>
           </a:p>
@@ -8634,7 +8634,7 @@
                 <a:ea typeface="Aptos" panose="020B0004020202020204" pitchFamily="34" charset="0"/>
                 <a:cs typeface="Aptos" panose="020B0004020202020204" pitchFamily="34" charset="0"/>
               </a:rPr>
-              <a:t>C^B = 0.8 kWh/K;</a:t>
+              <a:t>C^B = 50 kWh/K;</a:t>
             </a:r>
           </a:p>
           <a:p>

</xml_diff>